<commit_message>
Update live deployment docs and submit deck
</commit_message>
<xml_diff>
--- a/slides/nutrition-api-deck-updated.pptx
+++ b/slides/nutrition-api-deck-updated.pptx
@@ -1382,8 +1382,8 @@
         </p:blipFill>
         <p:spPr>
           <a:xfrm>
-            <a:off x="4947091" y="411480"/>
-            <a:ext cx="3648269" cy="4023360"/>
+            <a:off x="4832699" y="411480"/>
+            <a:ext cx="3762662" cy="4023360"/>
           </a:xfrm>
           <a:prstGeom prst="rect">
             <a:avLst/>
@@ -1398,8 +1398,8 @@
         </p:nvSpPr>
         <p:spPr>
           <a:xfrm>
-            <a:off x="4947091" y="411480"/>
-            <a:ext cx="3739709" cy="4023360"/>
+            <a:off x="4832699" y="546354"/>
+            <a:ext cx="3827976" cy="3888486"/>
           </a:xfrm>
           <a:prstGeom prst="rect">
             <a:avLst/>
@@ -1544,7 +1544,7 @@
         </p:nvSpPr>
         <p:spPr>
           <a:xfrm>
-            <a:off x="658368" y="3675888"/>
+            <a:off x="658368" y="3653028"/>
             <a:ext cx="3035808" cy="585216"/>
           </a:xfrm>
           <a:prstGeom prst="rect">
@@ -1751,7 +1751,7 @@
         </p:nvSpPr>
         <p:spPr>
           <a:xfrm>
-            <a:off x="7434072" y="384048"/>
+            <a:off x="7438644" y="410827"/>
             <a:ext cx="987552" cy="109728"/>
           </a:xfrm>
           <a:prstGeom prst="rect">
@@ -1790,7 +1790,7 @@
         </p:nvSpPr>
         <p:spPr>
           <a:xfrm>
-            <a:off x="658368" y="932688"/>
+            <a:off x="786384" y="960120"/>
             <a:ext cx="3977640" cy="676656"/>
           </a:xfrm>
           <a:prstGeom prst="rect">
@@ -1807,7 +1807,7 @@
               <a:buNone/>
             </a:pPr>
             <a:r>
-              <a:rPr lang="en-US" sz="2200" b="1" dirty="0">
+              <a:rPr lang="en-US" b="1" dirty="0">
                 <a:solidFill>
                   <a:srgbClr val="18212B"/>
                 </a:solidFill>
@@ -1817,7 +1817,7 @@
               </a:rPr>
               <a:t>A recipe API is a good coursework domain because it needs both transactions and calculation.</a:t>
             </a:r>
-            <a:endParaRPr lang="en-US" sz="2200" dirty="0"/>
+            <a:endParaRPr lang="en-US" dirty="0"/>
           </a:p>
         </p:txBody>
       </p:sp>
@@ -1829,7 +1829,7 @@
         </p:nvSpPr>
         <p:spPr>
           <a:xfrm>
-            <a:off x="786384" y="1783080"/>
+            <a:off x="786384" y="1901952"/>
             <a:ext cx="3566160" cy="1874520"/>
           </a:xfrm>
           <a:prstGeom prst="rect">
@@ -1967,7 +1967,7 @@
         </p:nvSpPr>
         <p:spPr>
           <a:xfrm>
-            <a:off x="5074920" y="1481328"/>
+            <a:off x="5052060" y="1810512"/>
             <a:ext cx="1463040" cy="182880"/>
           </a:xfrm>
           <a:prstGeom prst="rect">
@@ -2006,7 +2006,7 @@
         </p:nvSpPr>
         <p:spPr>
           <a:xfrm>
-            <a:off x="6016752" y="1828800"/>
+            <a:off x="5929884" y="1819656"/>
             <a:ext cx="182880" cy="164592"/>
           </a:xfrm>
           <a:prstGeom prst="rect">
@@ -2045,7 +2045,7 @@
         </p:nvSpPr>
         <p:spPr>
           <a:xfrm>
-            <a:off x="6382512" y="1883664"/>
+            <a:off x="6157458" y="1828800"/>
             <a:ext cx="1188720" cy="146304"/>
           </a:xfrm>
           <a:prstGeom prst="rect">
@@ -2084,7 +2084,7 @@
         </p:nvSpPr>
         <p:spPr>
           <a:xfrm>
-            <a:off x="7150608" y="1828800"/>
+            <a:off x="7301484" y="1828800"/>
             <a:ext cx="182880" cy="164592"/>
           </a:xfrm>
           <a:prstGeom prst="rect">
@@ -2123,7 +2123,7 @@
         </p:nvSpPr>
         <p:spPr>
           <a:xfrm>
-            <a:off x="7516368" y="1883664"/>
+            <a:off x="7596378" y="1839250"/>
             <a:ext cx="731520" cy="146304"/>
           </a:xfrm>
           <a:prstGeom prst="rect">
@@ -2857,8 +2857,8 @@
         </p:nvSpPr>
         <p:spPr>
           <a:xfrm>
-            <a:off x="2999232" y="1536192"/>
-            <a:ext cx="746760" cy="749808"/>
+            <a:off x="2999232" y="1399032"/>
+            <a:ext cx="746760" cy="649224"/>
           </a:xfrm>
           <a:prstGeom prst="rect">
             <a:avLst/>
@@ -2889,8 +2889,8 @@
         </p:nvSpPr>
         <p:spPr>
           <a:xfrm>
-            <a:off x="3054096" y="1792224"/>
-            <a:ext cx="637032" cy="146304"/>
+            <a:off x="3054096" y="1655064"/>
+            <a:ext cx="637032" cy="126678"/>
           </a:xfrm>
           <a:prstGeom prst="rect">
             <a:avLst/>
@@ -2928,8 +2928,8 @@
         </p:nvSpPr>
         <p:spPr>
           <a:xfrm>
-            <a:off x="3727704" y="1746504"/>
-            <a:ext cx="128016" cy="128016"/>
+            <a:off x="3727704" y="1681381"/>
+            <a:ext cx="128016" cy="110843"/>
           </a:xfrm>
           <a:prstGeom prst="rect">
             <a:avLst/>
@@ -2967,8 +2967,8 @@
         </p:nvSpPr>
         <p:spPr>
           <a:xfrm>
-            <a:off x="3837432" y="1536192"/>
-            <a:ext cx="746760" cy="749808"/>
+            <a:off x="3837432" y="1399032"/>
+            <a:ext cx="746760" cy="649224"/>
           </a:xfrm>
           <a:prstGeom prst="rect">
             <a:avLst/>
@@ -2999,8 +2999,8 @@
         </p:nvSpPr>
         <p:spPr>
           <a:xfrm>
-            <a:off x="3892296" y="1792224"/>
-            <a:ext cx="637032" cy="146304"/>
+            <a:off x="3892296" y="1655064"/>
+            <a:ext cx="637032" cy="126678"/>
           </a:xfrm>
           <a:prstGeom prst="rect">
             <a:avLst/>
@@ -3038,8 +3038,8 @@
         </p:nvSpPr>
         <p:spPr>
           <a:xfrm>
-            <a:off x="4565904" y="1746504"/>
-            <a:ext cx="128016" cy="128016"/>
+            <a:off x="4565904" y="1681381"/>
+            <a:ext cx="128016" cy="110843"/>
           </a:xfrm>
           <a:prstGeom prst="rect">
             <a:avLst/>
@@ -3077,8 +3077,8 @@
         </p:nvSpPr>
         <p:spPr>
           <a:xfrm>
-            <a:off x="4675632" y="1536192"/>
-            <a:ext cx="746760" cy="749808"/>
+            <a:off x="4675632" y="1399032"/>
+            <a:ext cx="746760" cy="649224"/>
           </a:xfrm>
           <a:prstGeom prst="rect">
             <a:avLst/>
@@ -3109,8 +3109,8 @@
         </p:nvSpPr>
         <p:spPr>
           <a:xfrm>
-            <a:off x="4730496" y="1792224"/>
-            <a:ext cx="637032" cy="146304"/>
+            <a:off x="4730496" y="1655064"/>
+            <a:ext cx="637032" cy="126678"/>
           </a:xfrm>
           <a:prstGeom prst="rect">
             <a:avLst/>
@@ -3148,8 +3148,8 @@
         </p:nvSpPr>
         <p:spPr>
           <a:xfrm>
-            <a:off x="5404104" y="1746504"/>
-            <a:ext cx="128016" cy="128016"/>
+            <a:off x="5404104" y="1681381"/>
+            <a:ext cx="128016" cy="110843"/>
           </a:xfrm>
           <a:prstGeom prst="rect">
             <a:avLst/>
@@ -3187,8 +3187,8 @@
         </p:nvSpPr>
         <p:spPr>
           <a:xfrm>
-            <a:off x="5513832" y="1536192"/>
-            <a:ext cx="746760" cy="749808"/>
+            <a:off x="5513832" y="1399032"/>
+            <a:ext cx="746760" cy="649224"/>
           </a:xfrm>
           <a:prstGeom prst="rect">
             <a:avLst/>
@@ -3219,8 +3219,8 @@
         </p:nvSpPr>
         <p:spPr>
           <a:xfrm>
-            <a:off x="5568696" y="1792224"/>
-            <a:ext cx="637032" cy="146304"/>
+            <a:off x="5568696" y="1655064"/>
+            <a:ext cx="637032" cy="126678"/>
           </a:xfrm>
           <a:prstGeom prst="rect">
             <a:avLst/>
@@ -3258,8 +3258,8 @@
         </p:nvSpPr>
         <p:spPr>
           <a:xfrm>
-            <a:off x="6242304" y="1746504"/>
-            <a:ext cx="128016" cy="128016"/>
+            <a:off x="6242304" y="1681381"/>
+            <a:ext cx="128016" cy="110843"/>
           </a:xfrm>
           <a:prstGeom prst="rect">
             <a:avLst/>
@@ -3297,8 +3297,8 @@
         </p:nvSpPr>
         <p:spPr>
           <a:xfrm>
-            <a:off x="6352032" y="1536192"/>
-            <a:ext cx="746760" cy="749808"/>
+            <a:off x="6352032" y="1399032"/>
+            <a:ext cx="746760" cy="649224"/>
           </a:xfrm>
           <a:prstGeom prst="rect">
             <a:avLst/>
@@ -3329,8 +3329,8 @@
         </p:nvSpPr>
         <p:spPr>
           <a:xfrm>
-            <a:off x="6406896" y="1792224"/>
-            <a:ext cx="637032" cy="146304"/>
+            <a:off x="6406896" y="1655064"/>
+            <a:ext cx="637032" cy="126678"/>
           </a:xfrm>
           <a:prstGeom prst="rect">
             <a:avLst/>
@@ -3368,8 +3368,8 @@
         </p:nvSpPr>
         <p:spPr>
           <a:xfrm>
-            <a:off x="7080504" y="1746504"/>
-            <a:ext cx="128016" cy="128016"/>
+            <a:off x="7080504" y="1681381"/>
+            <a:ext cx="128016" cy="110843"/>
           </a:xfrm>
           <a:prstGeom prst="rect">
             <a:avLst/>
@@ -3407,8 +3407,8 @@
         </p:nvSpPr>
         <p:spPr>
           <a:xfrm>
-            <a:off x="7190232" y="1536192"/>
-            <a:ext cx="746760" cy="749808"/>
+            <a:off x="7190232" y="1399032"/>
+            <a:ext cx="746760" cy="649224"/>
           </a:xfrm>
           <a:prstGeom prst="rect">
             <a:avLst/>
@@ -3439,8 +3439,8 @@
         </p:nvSpPr>
         <p:spPr>
           <a:xfrm>
-            <a:off x="7245096" y="1792224"/>
-            <a:ext cx="637032" cy="146304"/>
+            <a:off x="7245096" y="1655064"/>
+            <a:ext cx="637032" cy="126678"/>
           </a:xfrm>
           <a:prstGeom prst="rect">
             <a:avLst/>
@@ -3478,7 +3478,7 @@
         </p:nvSpPr>
         <p:spPr>
           <a:xfrm>
-            <a:off x="2999232" y="2450592"/>
+            <a:off x="3022092" y="2119915"/>
             <a:ext cx="4892040" cy="731520"/>
           </a:xfrm>
           <a:prstGeom prst="rect">
@@ -3764,7 +3764,7 @@
         </p:nvSpPr>
         <p:spPr>
           <a:xfrm>
-            <a:off x="7434072" y="384048"/>
+            <a:off x="7434072" y="402336"/>
             <a:ext cx="987552" cy="109728"/>
           </a:xfrm>
           <a:prstGeom prst="rect">
@@ -3803,8 +3803,8 @@
         </p:nvSpPr>
         <p:spPr>
           <a:xfrm>
-            <a:off x="640080" y="987552"/>
-            <a:ext cx="5349240" cy="2852928"/>
+            <a:off x="640080" y="987551"/>
+            <a:ext cx="4432041" cy="3166431"/>
           </a:xfrm>
           <a:prstGeom prst="rect">
             <a:avLst/>
@@ -3881,8 +3881,8 @@
         </p:blipFill>
         <p:spPr>
           <a:xfrm>
-            <a:off x="859536" y="1463040"/>
-            <a:ext cx="4892040" cy="2103120"/>
+            <a:off x="726854" y="1517905"/>
+            <a:ext cx="4259405" cy="2396101"/>
           </a:xfrm>
           <a:prstGeom prst="rect">
             <a:avLst/>
@@ -3897,8 +3897,8 @@
         </p:nvSpPr>
         <p:spPr>
           <a:xfrm>
-            <a:off x="6236208" y="987552"/>
-            <a:ext cx="2267712" cy="2852928"/>
+            <a:off x="5419220" y="987551"/>
+            <a:ext cx="3084700" cy="3166433"/>
           </a:xfrm>
           <a:prstGeom prst="rect">
             <a:avLst/>
@@ -3929,7 +3929,7 @@
         </p:nvSpPr>
         <p:spPr>
           <a:xfrm>
-            <a:off x="6446520" y="1170432"/>
+            <a:off x="5534919" y="1140947"/>
             <a:ext cx="1280160" cy="164592"/>
           </a:xfrm>
           <a:prstGeom prst="rect">
@@ -3968,8 +3968,8 @@
         </p:nvSpPr>
         <p:spPr>
           <a:xfrm>
-            <a:off x="6446520" y="1444752"/>
-            <a:ext cx="1810512" cy="749808"/>
+            <a:off x="5534919" y="1223990"/>
+            <a:ext cx="2722113" cy="749808"/>
           </a:xfrm>
           <a:prstGeom prst="rect">
             <a:avLst/>
@@ -4014,8 +4014,8 @@
         </p:blipFill>
         <p:spPr>
           <a:xfrm>
-            <a:off x="6419088" y="2240280"/>
-            <a:ext cx="1883664" cy="1078992"/>
+            <a:off x="5581012" y="1868702"/>
+            <a:ext cx="2676020" cy="1210400"/>
           </a:xfrm>
           <a:prstGeom prst="rect">
             <a:avLst/>
@@ -4030,7 +4030,7 @@
         </p:nvSpPr>
         <p:spPr>
           <a:xfrm>
-            <a:off x="6446520" y="3401568"/>
+            <a:off x="5534919" y="3159617"/>
             <a:ext cx="1280160" cy="137160"/>
           </a:xfrm>
           <a:prstGeom prst="rect">
@@ -4069,7 +4069,7 @@
         </p:nvSpPr>
         <p:spPr>
           <a:xfrm>
-            <a:off x="6446520" y="3584448"/>
+            <a:off x="6199258" y="3478354"/>
             <a:ext cx="1810512" cy="512064"/>
           </a:xfrm>
           <a:prstGeom prst="rect">
@@ -4706,8 +4706,8 @@
         </p:nvSpPr>
         <p:spPr>
           <a:xfrm>
-            <a:off x="3328416" y="2651760"/>
-            <a:ext cx="1572768" cy="950976"/>
+            <a:off x="3328416" y="2651759"/>
+            <a:ext cx="1572768" cy="1080485"/>
           </a:xfrm>
           <a:prstGeom prst="rect">
             <a:avLst/>
@@ -4904,7 +4904,7 @@
         </p:nvSpPr>
         <p:spPr>
           <a:xfrm>
-            <a:off x="5650992" y="1353312"/>
+            <a:off x="5650992" y="1207008"/>
             <a:ext cx="1554480" cy="164592"/>
           </a:xfrm>
           <a:prstGeom prst="rect">
@@ -4943,7 +4943,7 @@
         </p:nvSpPr>
         <p:spPr>
           <a:xfrm>
-            <a:off x="5650992" y="1755648"/>
+            <a:off x="5650992" y="1408176"/>
             <a:ext cx="1920240" cy="384048"/>
           </a:xfrm>
           <a:prstGeom prst="rect">
@@ -4982,7 +4982,7 @@
         </p:nvSpPr>
         <p:spPr>
           <a:xfrm>
-            <a:off x="5650992" y="2267712"/>
+            <a:off x="5650992" y="2784349"/>
             <a:ext cx="2331720" cy="566928"/>
           </a:xfrm>
           <a:prstGeom prst="rect">
@@ -5021,7 +5021,7 @@
         </p:nvSpPr>
         <p:spPr>
           <a:xfrm>
-            <a:off x="5650992" y="2999232"/>
+            <a:off x="5650992" y="3364992"/>
             <a:ext cx="2395728" cy="475488"/>
           </a:xfrm>
           <a:prstGeom prst="rect">
@@ -5114,6 +5114,36 @@
           </a:p>
         </p:txBody>
       </p:sp>
+      <p:pic>
+        <p:nvPicPr>
+          <p:cNvPr id="26" name="图片 25">
+            <a:extLst>
+              <a:ext uri="{FF2B5EF4-FFF2-40B4-BE49-F238E27FC236}">
+                <a16:creationId xmlns:a16="http://schemas.microsoft.com/office/drawing/2014/main" id="{C5880081-5B33-F739-E139-682EC821159C}"/>
+              </a:ext>
+            </a:extLst>
+          </p:cNvPr>
+          <p:cNvPicPr>
+            <a:picLocks noChangeAspect="1"/>
+          </p:cNvPicPr>
+          <p:nvPr/>
+        </p:nvPicPr>
+        <p:blipFill>
+          <a:blip r:embed="rId3"/>
+          <a:stretch>
+            <a:fillRect/>
+          </a:stretch>
+        </p:blipFill>
+        <p:spPr>
+          <a:xfrm>
+            <a:off x="5508047" y="1828800"/>
+            <a:ext cx="2864498" cy="1021151"/>
+          </a:xfrm>
+          <a:prstGeom prst="rect">
+            <a:avLst/>
+          </a:prstGeom>
+        </p:spPr>
+      </p:pic>
     </p:spTree>
   </p:cSld>
   <p:clrMapOvr>
@@ -5259,7 +5289,7 @@
         <p:spPr>
           <a:xfrm>
             <a:off x="444520" y="987551"/>
-            <a:ext cx="4950440" cy="3058187"/>
+            <a:ext cx="4950440" cy="3364245"/>
           </a:xfrm>
           <a:prstGeom prst="rect">
             <a:avLst/>
@@ -5330,7 +5360,7 @@
         <p:spPr>
           <a:xfrm>
             <a:off x="5467324" y="987551"/>
-            <a:ext cx="2981732" cy="3058187"/>
+            <a:ext cx="2981732" cy="3364245"/>
           </a:xfrm>
           <a:prstGeom prst="rect">
             <a:avLst/>
@@ -5361,7 +5391,7 @@
         </p:nvSpPr>
         <p:spPr>
           <a:xfrm>
-            <a:off x="5741274" y="1134787"/>
+            <a:off x="5549623" y="1115567"/>
             <a:ext cx="1720230" cy="172023"/>
           </a:xfrm>
           <a:prstGeom prst="rect">
@@ -5407,8 +5437,8 @@
         </p:blipFill>
         <p:spPr>
           <a:xfrm>
-            <a:off x="5500740" y="1429465"/>
-            <a:ext cx="2911740" cy="2243421"/>
+            <a:off x="5493235" y="1419994"/>
+            <a:ext cx="2911740" cy="2303511"/>
           </a:xfrm>
           <a:prstGeom prst="rect">
             <a:avLst/>
@@ -5423,7 +5453,7 @@
         </p:nvSpPr>
         <p:spPr>
           <a:xfrm>
-            <a:off x="5721680" y="3706402"/>
+            <a:off x="5741274" y="3898316"/>
             <a:ext cx="2427438" cy="305819"/>
           </a:xfrm>
           <a:prstGeom prst="rect">
@@ -5538,8 +5568,8 @@
         </p:blipFill>
         <p:spPr>
           <a:xfrm>
-            <a:off x="542795" y="1263000"/>
-            <a:ext cx="4797966" cy="2617500"/>
+            <a:off x="542795" y="1262999"/>
+            <a:ext cx="4797966" cy="2995492"/>
           </a:xfrm>
           <a:prstGeom prst="rect">
             <a:avLst/>
@@ -6234,7 +6264,7 @@
         </p:nvSpPr>
         <p:spPr>
           <a:xfrm>
-            <a:off x="7434072" y="384048"/>
+            <a:off x="7434072" y="402336"/>
             <a:ext cx="987552" cy="109728"/>
           </a:xfrm>
           <a:prstGeom prst="rect">
@@ -7328,7 +7358,7 @@
         </p:nvSpPr>
         <p:spPr>
           <a:xfrm>
-            <a:off x="4736592" y="3054096"/>
+            <a:off x="4736592" y="3127248"/>
             <a:ext cx="3703320" cy="841248"/>
           </a:xfrm>
           <a:prstGeom prst="rect">

</xml_diff>